<commit_message>
Improve boolq answer visibility and citation wording
</commit_message>
<xml_diff>
--- a/slides/datasets-in-10-minutes-boolq.pptx
+++ b/slides/datasets-in-10-minutes-boolq.pptx
@@ -12470,7 +12470,7 @@
                 <a:ea typeface="Noto Sans CJK JP"/>
                 <a:cs typeface="Noto Sans"/>
               </a:rPr>
-              <a:t>論文Table 4。BoolQの学習集合で微調整し、非公開のテスト集合で評価。</a:t>
+              <a:t>BoolQの学習集合で微調整し、非公開のテスト集合で評価。</a:t>
             </a:r>
           </a:p>
         </p:txBody>
@@ -16672,7 +16672,7 @@
         <p:spPr>
           <a:xfrm>
             <a:off x="6766560" y="1344168"/>
-            <a:ext cx="1783080" cy="237744"/>
+            <a:ext cx="1783080" cy="386693"/>
           </a:xfrm>
           <a:prstGeom prst="rect">
             <a:avLst/>
@@ -16687,7 +16687,7 @@
           <a:p>
             <a:pPr algn="r">
               <a:lnSpc>
-                <a:spcPct val="117000"/>
+                <a:spcPts val="2640"/>
               </a:lnSpc>
               <a:spcBef>
                 <a:spcPts val="0"/>
@@ -16704,9 +16704,9 @@
               </a:defRPr>
             </a:pPr>
             <a:r>
-              <a:rPr sz="1450" b="1" lang="ja-JP" altLang="en-US">
-                <a:solidFill>
-                  <a:srgbClr val="2C9100"/>
+              <a:rPr sz="2200" b="1" lang="ja-JP" altLang="en-US">
+                <a:solidFill>
+                  <a:schemeClr val="accent1"/>
                 </a:solidFill>
                 <a:latin typeface="Noto Sans"/>
                 <a:ea typeface="Noto Sans CJK JP"/>
@@ -17161,7 +17161,7 @@
         <p:spPr>
           <a:xfrm>
             <a:off x="6766560" y="1344168"/>
-            <a:ext cx="1783080" cy="237744"/>
+            <a:ext cx="1783080" cy="386693"/>
           </a:xfrm>
           <a:prstGeom prst="rect">
             <a:avLst/>
@@ -17176,7 +17176,7 @@
           <a:p>
             <a:pPr algn="r">
               <a:lnSpc>
-                <a:spcPct val="117000"/>
+                <a:spcPts val="2640"/>
               </a:lnSpc>
               <a:spcBef>
                 <a:spcPts val="0"/>
@@ -17193,9 +17193,9 @@
               </a:defRPr>
             </a:pPr>
             <a:r>
-              <a:rPr sz="1450" b="1" lang="ja-JP" altLang="en-US">
-                <a:solidFill>
-                  <a:srgbClr val="2C9100"/>
+              <a:rPr sz="2200" b="1" lang="ja-JP" altLang="en-US">
+                <a:solidFill>
+                  <a:schemeClr val="accent1"/>
                 </a:solidFill>
                 <a:latin typeface="Noto Sans"/>
                 <a:ea typeface="Noto Sans CJK JP"/>
@@ -17650,7 +17650,7 @@
         <p:spPr>
           <a:xfrm>
             <a:off x="6766560" y="1344168"/>
-            <a:ext cx="1783080" cy="237744"/>
+            <a:ext cx="1783080" cy="386693"/>
           </a:xfrm>
           <a:prstGeom prst="rect">
             <a:avLst/>
@@ -17665,7 +17665,7 @@
           <a:p>
             <a:pPr algn="r">
               <a:lnSpc>
-                <a:spcPct val="117000"/>
+                <a:spcPts val="2640"/>
               </a:lnSpc>
               <a:spcBef>
                 <a:spcPts val="0"/>
@@ -17682,9 +17682,9 @@
               </a:defRPr>
             </a:pPr>
             <a:r>
-              <a:rPr sz="1450" b="1" lang="ja-JP" altLang="en-US">
-                <a:solidFill>
-                  <a:srgbClr val="2C9100"/>
+              <a:rPr sz="2200" b="1" lang="ja-JP" altLang="en-US">
+                <a:solidFill>
+                  <a:schemeClr val="accent1"/>
                 </a:solidFill>
                 <a:latin typeface="Noto Sans"/>
                 <a:ea typeface="Noto Sans CJK JP"/>
@@ -19687,7 +19687,7 @@
         <p:spPr>
           <a:xfrm>
             <a:off x="6766560" y="1344168"/>
-            <a:ext cx="1783080" cy="237744"/>
+            <a:ext cx="1783080" cy="386693"/>
           </a:xfrm>
           <a:prstGeom prst="rect">
             <a:avLst/>
@@ -19702,7 +19702,7 @@
           <a:p>
             <a:pPr algn="r">
               <a:lnSpc>
-                <a:spcPct val="117000"/>
+                <a:spcPts val="2640"/>
               </a:lnSpc>
               <a:spcBef>
                 <a:spcPts val="0"/>
@@ -19719,9 +19719,9 @@
               </a:defRPr>
             </a:pPr>
             <a:r>
-              <a:rPr sz="1450" b="1" lang="ja-JP" altLang="en-US">
-                <a:solidFill>
-                  <a:srgbClr val="2C9100"/>
+              <a:rPr sz="2200" b="1" lang="ja-JP" altLang="en-US">
+                <a:solidFill>
+                  <a:schemeClr val="accent1"/>
                 </a:solidFill>
                 <a:latin typeface="Noto Sans"/>
                 <a:ea typeface="Noto Sans CJK JP"/>
@@ -20654,7 +20654,7 @@
         <p:spPr>
           <a:xfrm>
             <a:off x="6766560" y="1344168"/>
-            <a:ext cx="1783080" cy="237744"/>
+            <a:ext cx="1783080" cy="386693"/>
           </a:xfrm>
           <a:prstGeom prst="rect">
             <a:avLst/>
@@ -20669,7 +20669,7 @@
           <a:p>
             <a:pPr algn="r">
               <a:lnSpc>
-                <a:spcPct val="117000"/>
+                <a:spcPts val="2640"/>
               </a:lnSpc>
               <a:spcBef>
                 <a:spcPts val="0"/>
@@ -20686,9 +20686,9 @@
               </a:defRPr>
             </a:pPr>
             <a:r>
-              <a:rPr sz="1450" b="1" lang="ja-JP" altLang="en-US">
-                <a:solidFill>
-                  <a:srgbClr val="2C9100"/>
+              <a:rPr sz="2200" b="1" lang="ja-JP" altLang="en-US">
+                <a:solidFill>
+                  <a:schemeClr val="accent1"/>
                 </a:solidFill>
                 <a:latin typeface="Noto Sans"/>
                 <a:ea typeface="Noto Sans CJK JP"/>
@@ -26346,7 +26346,7 @@
         <p:spPr>
           <a:xfrm>
             <a:off x="6766560" y="1344168"/>
-            <a:ext cx="1783080" cy="237744"/>
+            <a:ext cx="1783080" cy="386693"/>
           </a:xfrm>
           <a:prstGeom prst="rect">
             <a:avLst/>
@@ -26361,7 +26361,7 @@
           <a:p>
             <a:pPr algn="r">
               <a:lnSpc>
-                <a:spcPct val="117000"/>
+                <a:spcPts val="2640"/>
               </a:lnSpc>
               <a:spcBef>
                 <a:spcPts val="0"/>
@@ -26378,9 +26378,9 @@
               </a:defRPr>
             </a:pPr>
             <a:r>
-              <a:rPr sz="1450" b="1" lang="ja-JP" altLang="en-US">
-                <a:solidFill>
-                  <a:srgbClr val="2C9100"/>
+              <a:rPr sz="2200" b="1" lang="ja-JP" altLang="en-US">
+                <a:solidFill>
+                  <a:schemeClr val="accent1"/>
                 </a:solidFill>
                 <a:latin typeface="Noto Sans"/>
                 <a:ea typeface="Noto Sans CJK JP"/>

</xml_diff>